<commit_message>
Align M08 date fit with simulation plan
Co-authored-by: shaseaver25 <shannon@tailoredu.org>
</commit_message>
<xml_diff>
--- a/teaching-pack/12-M08-spurious-correlation/M08-instructor-reveal.pptx
+++ b/teaching-pack/12-M08-spurious-correlation/M08-instructor-reveal.pptx
@@ -4592,7 +4592,7 @@
                 </a:solidFill>
                 <a:latin typeface="Arial"/>
               </a:rPr>
-              <a:t>Slope: 7.95 µε/day</a:t>
+              <a:t>Slope: 8.12 µε/day</a:t>
             </a:r>
           </a:p>
           <a:p>
@@ -4611,7 +4611,7 @@
                 </a:solidFill>
                 <a:latin typeface="Arial"/>
               </a:rPr>
-              <a:t>R²: 0.891</a:t>
+              <a:t>R²: 0.870</a:t>
             </a:r>
           </a:p>
           <a:p>
@@ -4909,7 +4909,7 @@
                 </a:solidFill>
                 <a:latin typeface="Arial"/>
               </a:rPr>
-              <a:t>Slope: 11.78 µε/°C</a:t>
+              <a:t>Slope: 11.90 µε/°C</a:t>
             </a:r>
           </a:p>
           <a:p>
@@ -4928,7 +4928,7 @@
                 </a:solidFill>
                 <a:latin typeface="Arial"/>
               </a:rPr>
-              <a:t>R²: 0.975</a:t>
+              <a:t>R²: 0.933</a:t>
             </a:r>
           </a:p>
           <a:p>
@@ -5791,7 +5791,7 @@
                 </a:solidFill>
                 <a:latin typeface="Arial"/>
               </a:rPr>
-              <a:t>Slope: 0.17 µε/day</a:t>
+              <a:t>Slope: 0.26 µε/day</a:t>
             </a:r>
           </a:p>
           <a:p>
@@ -5810,7 +5810,7 @@
                 </a:solidFill>
                 <a:latin typeface="Arial"/>
               </a:rPr>
-              <a:t>R²: 0.017</a:t>
+              <a:t>R²: 0.013</a:t>
             </a:r>
           </a:p>
           <a:p>

</xml_diff>

<commit_message>
Fold Cloud-passed M08 SAY into teaching pack
Co-authored-by: shaseaver25 <shannon@tailoredu.org>
</commit_message>
<xml_diff>
--- a/teaching-pack/12-M08-spurious-correlation/M08-instructor-reveal.pptx
+++ b/teaching-pack/12-M08-spurious-correlation/M08-instructor-reveal.pptx
@@ -509,19 +509,13 @@
           <a:lstStyle/>
           <a:p>
             <a:r>
-              <a:t>OLI STORY/SAY STATUS: PENDING CLOUD PASS — DO NOT TREAT THIS HOOK AS CANON SAY.</a:t>
+              <a:t>OLI CANON SAY — Cloud hard-review PASS.</a:t>
             </a:r>
           </a:p>
           <a:p/>
           <a:p>
             <a:r>
-              <a:t>PASTE APPROVED SAY HERE, preserving the instructional action below.</a:t>
-            </a:r>
-          </a:p>
-          <a:p/>
-          <a:p>
-            <a:r>
-              <a:t>REVEAL TITLE HOOK — Open only after students commit H8-02 and Note v2.</a:t>
+              <a:t>REVEAL — Open only after students complete the hunt and commit H8-02 and Note version 2.</a:t>
             </a:r>
           </a:p>
         </p:txBody>
@@ -591,19 +585,13 @@
           <a:lstStyle/>
           <a:p>
             <a:r>
-              <a:t>OLI STORY/SAY STATUS: PENDING CLOUD PASS — DO NOT TREAT THIS HOOK AS CANON SAY.</a:t>
+              <a:t>OLI CANON SAY — Cloud hard-review PASS.</a:t>
             </a:r>
           </a:p>
           <a:p/>
           <a:p>
             <a:r>
-              <a:t>PASTE APPROVED SAY HERE, preserving the instructional action below.</a:t>
-            </a:r>
-          </a:p>
-          <a:p/>
-          <a:p>
-            <a:r>
-              <a:t>REVEAL HOOK — Confirm the date-model values. Separate reproducible calculation from unsupported causal interpretation.</a:t>
+              <a:t>REVEAL — Confirm the date-model result. FOREMAN’s fitted line is reproducible; the progressive-deterioration interpretation is not supported.</a:t>
             </a:r>
           </a:p>
         </p:txBody>
@@ -673,19 +661,13 @@
           <a:lstStyle/>
           <a:p>
             <a:r>
-              <a:t>OLI STORY/SAY STATUS: PENDING CLOUD PASS — DO NOT TREAT THIS HOOK AS CANON SAY.</a:t>
+              <a:t>OLI CANON SAY — Cloud hard-review PASS.</a:t>
             </a:r>
           </a:p>
           <a:p/>
           <a:p>
             <a:r>
-              <a:t>PASTE APPROVED SAY HERE, preserving the instructional action below.</a:t>
-            </a:r>
-          </a:p>
-          <a:p/>
-          <a:p>
-            <a:r>
-              <a:t>REVEAL HOOK — Confirm the temperature-model values and elicit the physical mechanism.</a:t>
+              <a:t>REVEAL — Confirm that strain has a strong relationship with air temperature. Students, not Diane or Wes, identify the thermal-expansion mechanism.</a:t>
             </a:r>
           </a:p>
         </p:txBody>
@@ -755,19 +737,13 @@
           <a:lstStyle/>
           <a:p>
             <a:r>
-              <a:t>OLI STORY/SAY STATUS: PENDING CLOUD PASS — DO NOT TREAT THIS HOOK AS CANON SAY.</a:t>
+              <a:t>OLI CANON SAY — Cloud hard-review PASS.</a:t>
             </a:r>
           </a:p>
           <a:p/>
           <a:p>
             <a:r>
-              <a:t>PASTE APPROVED SAY HERE, preserving the instructional action below.</a:t>
-            </a:r>
-          </a:p>
-          <a:p/>
-          <a:p>
-            <a:r>
-              <a:t>REVEAL HOOK — Walk date → temperature → measured strain. Clarify that date is a proxy in this observed window.</a:t>
+              <a:t>REVEAL — Temperature drives the calendar trend and the measured strain: date → warming → steel expansion → measured strain.</a:t>
             </a:r>
           </a:p>
         </p:txBody>
@@ -837,19 +813,13 @@
           <a:lstStyle/>
           <a:p>
             <a:r>
-              <a:t>OLI STORY/SAY STATUS: PENDING CLOUD PASS — DO NOT TREAT THIS HOOK AS CANON SAY.</a:t>
+              <a:t>OLI CANON SAY — Cloud hard-review PASS.</a:t>
             </a:r>
           </a:p>
           <a:p/>
           <a:p>
             <a:r>
-              <a:t>PASTE APPROVED SAY HERE, preserving the instructional action below.</a:t>
-            </a:r>
-          </a:p>
-          <a:p/>
-          <a:p>
-            <a:r>
-              <a:t>REVEAL HOOK — Show residual model. Use 'no meaningful trend in this extract,' not 'proof of no damage.'</a:t>
+              <a:t>REVEAL — Confirm the temperature-corrected result. Use “no meaningful date trend in this extract,” not “proof of no damage.”</a:t>
             </a:r>
           </a:p>
         </p:txBody>
@@ -919,19 +889,13 @@
           <a:lstStyle/>
           <a:p>
             <a:r>
-              <a:t>OLI STORY/SAY STATUS: PENDING CLOUD PASS — DO NOT TREAT THIS HOOK AS CANON SAY.</a:t>
+              <a:t>OLI CANON SAY — Cloud hard-review PASS.</a:t>
             </a:r>
           </a:p>
           <a:p/>
           <a:p>
             <a:r>
-              <a:t>PASTE APPROVED SAY HERE, preserving the instructional action below.</a:t>
-            </a:r>
-          </a:p>
-          <a:p/>
-          <a:p>
-            <a:r>
-              <a:t>REVEAL HOOK — State the designed error: FOREMAN treated fit as proof of deterioration.</a:t>
+              <a:t>REVEAL — FOREMAN’s designed error is reading the seasonal temperature effect as structural damage and offering high R-squared as proof of cause.</a:t>
             </a:r>
           </a:p>
         </p:txBody>
@@ -1001,19 +965,13 @@
           <a:lstStyle/>
           <a:p>
             <a:r>
-              <a:t>OLI STORY/SAY STATUS: PENDING CLOUD PASS — DO NOT TREAT THIS HOOK AS CANON SAY.</a:t>
+              <a:t>OLI CANON SAY — Cloud hard-review PASS.</a:t>
             </a:r>
           </a:p>
           <a:p/>
           <a:p>
             <a:r>
-              <a:t>PASTE APPROVED SAY HERE, preserving the instructional action below.</a:t>
-            </a:r>
-          </a:p>
-          <a:p/>
-          <a:p>
-            <a:r>
-              <a:t>MODEL RESPONSE HOOK — Compare student boundaries; accept equivalent evidence-based wording.</a:t>
+              <a:t>REVEAL — Compare student replies. The supported conclusion is that this uncorrected trend does not establish progressive structural deterioration.</a:t>
             </a:r>
           </a:p>
         </p:txBody>
@@ -1083,19 +1041,13 @@
           <a:lstStyle/>
           <a:p>
             <a:r>
-              <a:t>OLI STORY/SAY STATUS: PENDING CLOUD PASS — DO NOT TREAT THIS HOOK AS CANON SAY.</a:t>
+              <a:t>OLI CANON SAY — Cloud hard-review PASS.</a:t>
             </a:r>
           </a:p>
           <a:p/>
           <a:p>
             <a:r>
-              <a:t>PASTE APPROVED SAY HERE, preserving the instructional action below.</a:t>
-            </a:r>
-          </a:p>
-          <a:p/>
-          <a:p>
-            <a:r>
-              <a:t>CLOSE HOOK — Assign HW4 and collect Note v2. Approved Oli story close may be pasted here later.</a:t>
+              <a:t>CLOSE — HW4 stays at M08: temperature-corrected strain trend plus a two-line reply. Continue Note version 2 from M07. Diane remains in believer mode and students retain the corrected record.</a:t>
             </a:r>
           </a:p>
         </p:txBody>

</xml_diff>